<commit_message>
Docs: Update PowerPoint slides with project logo, database ERD, and UI screenshots
</commit_message>
<xml_diff>
--- a/docs/TravelConnect_Slides.pptx
+++ b/docs/TravelConnect_Slides.pptx
@@ -3105,15 +3105,39 @@
         <p:nvPr/>
       </p:nvGrpSpPr>
       <p:grpSpPr/>
-      <p:sp>
-        <p:nvSpPr>
-          <p:cNvPr id="2" name="TextBox 1"/>
+      <p:pic>
+        <p:nvPicPr>
+          <p:cNvPr id="2" name="Picture 1" descr="logo.png"/>
+          <p:cNvPicPr>
+            <a:picLocks noChangeAspect="1"/>
+          </p:cNvPicPr>
+          <p:nvPr/>
+        </p:nvPicPr>
+        <p:blipFill>
+          <a:blip r:embed="rId2"/>
+          <a:stretch>
+            <a:fillRect/>
+          </a:stretch>
+        </p:blipFill>
+        <p:spPr>
+          <a:xfrm>
+            <a:off x="914400" y="731520"/>
+            <a:ext cx="1097280" cy="1097280"/>
+          </a:xfrm>
+          <a:prstGeom prst="rect">
+            <a:avLst/>
+          </a:prstGeom>
+        </p:spPr>
+      </p:pic>
+      <p:sp>
+        <p:nvSpPr>
+          <p:cNvPr id="3" name="TextBox 2"/>
           <p:cNvSpPr txBox="1"/>
           <p:nvPr/>
         </p:nvSpPr>
         <p:spPr>
           <a:xfrm>
-            <a:off x="914400" y="1371600"/>
+            <a:off x="914400" y="2011680"/>
             <a:ext cx="10362895" cy="548640"/>
           </a:xfrm>
           <a:prstGeom prst="rect">
@@ -3143,13 +3167,13 @@
       </p:sp>
       <p:sp>
         <p:nvSpPr>
-          <p:cNvPr id="3" name="TextBox 2"/>
+          <p:cNvPr id="4" name="TextBox 3"/>
           <p:cNvSpPr txBox="1"/>
           <p:nvPr/>
         </p:nvSpPr>
         <p:spPr>
           <a:xfrm>
-            <a:off x="914400" y="2011680"/>
+            <a:off x="914400" y="2560320"/>
             <a:ext cx="10362895" cy="1828800"/>
           </a:xfrm>
           <a:prstGeom prst="rect">
@@ -3179,13 +3203,13 @@
       </p:sp>
       <p:sp>
         <p:nvSpPr>
-          <p:cNvPr id="4" name="TextBox 3"/>
+          <p:cNvPr id="5" name="TextBox 4"/>
           <p:cNvSpPr txBox="1"/>
           <p:nvPr/>
         </p:nvSpPr>
         <p:spPr>
           <a:xfrm>
-            <a:off x="914400" y="4114800"/>
+            <a:off x="914400" y="4572000"/>
             <a:ext cx="7315200" cy="1828800"/>
           </a:xfrm>
           <a:prstGeom prst="rect">
@@ -3244,13 +3268,13 @@
       </p:sp>
       <p:sp>
         <p:nvSpPr>
-          <p:cNvPr id="5" name="Rectangle 4"/>
+          <p:cNvPr id="6" name="Rectangle 5"/>
           <p:cNvSpPr/>
           <p:nvPr/>
         </p:nvSpPr>
         <p:spPr>
           <a:xfrm>
-            <a:off x="914400" y="3931920"/>
+            <a:off x="914400" y="4389120"/>
             <a:ext cx="2743200" cy="45720"/>
           </a:xfrm>
           <a:prstGeom prst="rect">
@@ -3461,7 +3485,7 @@
         <p:spPr>
           <a:xfrm>
             <a:off x="457200" y="182880"/>
-            <a:ext cx="11277295" cy="731520"/>
+            <a:ext cx="9144000" cy="731520"/>
           </a:xfrm>
           <a:prstGeom prst="rect">
             <a:avLst/>
@@ -3488,9 +3512,33 @@
           </a:p>
         </p:txBody>
       </p:sp>
-      <p:sp>
-        <p:nvSpPr>
-          <p:cNvPr id="4" name="Rounded Rectangle 3"/>
+      <p:pic>
+        <p:nvPicPr>
+          <p:cNvPr id="4" name="Picture 3" descr="logo.png"/>
+          <p:cNvPicPr>
+            <a:picLocks noChangeAspect="1"/>
+          </p:cNvPicPr>
+          <p:nvPr/>
+        </p:nvPicPr>
+        <p:blipFill>
+          <a:blip r:embed="rId2"/>
+          <a:stretch>
+            <a:fillRect/>
+          </a:stretch>
+        </p:blipFill>
+        <p:spPr>
+          <a:xfrm>
+            <a:off x="10972800" y="182880"/>
+            <a:ext cx="731520" cy="731520"/>
+          </a:xfrm>
+          <a:prstGeom prst="rect">
+            <a:avLst/>
+          </a:prstGeom>
+        </p:spPr>
+      </p:pic>
+      <p:sp>
+        <p:nvSpPr>
+          <p:cNvPr id="5" name="Rounded Rectangle 4"/>
           <p:cNvSpPr/>
           <p:nvPr/>
         </p:nvSpPr>
@@ -3535,7 +3583,7 @@
       </p:sp>
       <p:sp>
         <p:nvSpPr>
-          <p:cNvPr id="5" name="TextBox 4"/>
+          <p:cNvPr id="6" name="TextBox 5"/>
           <p:cNvSpPr txBox="1"/>
           <p:nvPr/>
         </p:nvSpPr>
@@ -3622,7 +3670,7 @@
       </p:sp>
       <p:sp>
         <p:nvSpPr>
-          <p:cNvPr id="6" name="Rounded Rectangle 5"/>
+          <p:cNvPr id="7" name="Rounded Rectangle 6"/>
           <p:cNvSpPr/>
           <p:nvPr/>
         </p:nvSpPr>
@@ -3662,7 +3710,7 @@
       </p:sp>
       <p:sp>
         <p:nvSpPr>
-          <p:cNvPr id="7" name="TextBox 6"/>
+          <p:cNvPr id="8" name="TextBox 7"/>
           <p:cNvSpPr txBox="1"/>
           <p:nvPr/>
         </p:nvSpPr>
@@ -3825,7 +3873,7 @@
         <p:spPr>
           <a:xfrm>
             <a:off x="457200" y="182880"/>
-            <a:ext cx="11277295" cy="731520"/>
+            <a:ext cx="9144000" cy="731520"/>
           </a:xfrm>
           <a:prstGeom prst="rect">
             <a:avLst/>
@@ -3852,9 +3900,33 @@
           </a:p>
         </p:txBody>
       </p:sp>
-      <p:sp>
-        <p:nvSpPr>
-          <p:cNvPr id="4" name="Rounded Rectangle 3"/>
+      <p:pic>
+        <p:nvPicPr>
+          <p:cNvPr id="4" name="Picture 3" descr="logo.png"/>
+          <p:cNvPicPr>
+            <a:picLocks noChangeAspect="1"/>
+          </p:cNvPicPr>
+          <p:nvPr/>
+        </p:nvPicPr>
+        <p:blipFill>
+          <a:blip r:embed="rId2"/>
+          <a:stretch>
+            <a:fillRect/>
+          </a:stretch>
+        </p:blipFill>
+        <p:spPr>
+          <a:xfrm>
+            <a:off x="10972800" y="182880"/>
+            <a:ext cx="731520" cy="731520"/>
+          </a:xfrm>
+          <a:prstGeom prst="rect">
+            <a:avLst/>
+          </a:prstGeom>
+        </p:spPr>
+      </p:pic>
+      <p:sp>
+        <p:nvSpPr>
+          <p:cNvPr id="5" name="Rounded Rectangle 4"/>
           <p:cNvSpPr/>
           <p:nvPr/>
         </p:nvSpPr>
@@ -3899,7 +3971,7 @@
       </p:sp>
       <p:sp>
         <p:nvSpPr>
-          <p:cNvPr id="5" name="TextBox 4"/>
+          <p:cNvPr id="6" name="TextBox 5"/>
           <p:cNvSpPr txBox="1"/>
           <p:nvPr/>
         </p:nvSpPr>
@@ -4002,7 +4074,7 @@
       </p:sp>
       <p:sp>
         <p:nvSpPr>
-          <p:cNvPr id="6" name="Rounded Rectangle 5"/>
+          <p:cNvPr id="7" name="Rounded Rectangle 6"/>
           <p:cNvSpPr/>
           <p:nvPr/>
         </p:nvSpPr>
@@ -4047,7 +4119,7 @@
       </p:sp>
       <p:sp>
         <p:nvSpPr>
-          <p:cNvPr id="7" name="TextBox 6"/>
+          <p:cNvPr id="8" name="TextBox 7"/>
           <p:cNvSpPr txBox="1"/>
           <p:nvPr/>
         </p:nvSpPr>
@@ -4150,7 +4222,7 @@
       </p:sp>
       <p:sp>
         <p:nvSpPr>
-          <p:cNvPr id="8" name="Rounded Rectangle 7"/>
+          <p:cNvPr id="9" name="Rounded Rectangle 8"/>
           <p:cNvSpPr/>
           <p:nvPr/>
         </p:nvSpPr>
@@ -4195,7 +4267,7 @@
       </p:sp>
       <p:sp>
         <p:nvSpPr>
-          <p:cNvPr id="9" name="TextBox 8"/>
+          <p:cNvPr id="10" name="TextBox 9"/>
           <p:cNvSpPr txBox="1"/>
           <p:nvPr/>
         </p:nvSpPr>
@@ -4374,7 +4446,7 @@
         <p:spPr>
           <a:xfrm>
             <a:off x="457200" y="182880"/>
-            <a:ext cx="11277295" cy="731520"/>
+            <a:ext cx="9144000" cy="731520"/>
           </a:xfrm>
           <a:prstGeom prst="rect">
             <a:avLst/>
@@ -4401,9 +4473,33 @@
           </a:p>
         </p:txBody>
       </p:sp>
-      <p:sp>
-        <p:nvSpPr>
-          <p:cNvPr id="4" name="Rounded Rectangle 3"/>
+      <p:pic>
+        <p:nvPicPr>
+          <p:cNvPr id="4" name="Picture 3" descr="logo.png"/>
+          <p:cNvPicPr>
+            <a:picLocks noChangeAspect="1"/>
+          </p:cNvPicPr>
+          <p:nvPr/>
+        </p:nvPicPr>
+        <p:blipFill>
+          <a:blip r:embed="rId2"/>
+          <a:stretch>
+            <a:fillRect/>
+          </a:stretch>
+        </p:blipFill>
+        <p:spPr>
+          <a:xfrm>
+            <a:off x="10972800" y="182880"/>
+            <a:ext cx="731520" cy="731520"/>
+          </a:xfrm>
+          <a:prstGeom prst="rect">
+            <a:avLst/>
+          </a:prstGeom>
+        </p:spPr>
+      </p:pic>
+      <p:sp>
+        <p:nvSpPr>
+          <p:cNvPr id="5" name="Rounded Rectangle 4"/>
           <p:cNvSpPr/>
           <p:nvPr/>
         </p:nvSpPr>
@@ -4448,7 +4544,7 @@
       </p:sp>
       <p:sp>
         <p:nvSpPr>
-          <p:cNvPr id="5" name="TextBox 4"/>
+          <p:cNvPr id="6" name="TextBox 5"/>
           <p:cNvSpPr txBox="1"/>
           <p:nvPr/>
         </p:nvSpPr>
@@ -4535,7 +4631,7 @@
       </p:sp>
       <p:sp>
         <p:nvSpPr>
-          <p:cNvPr id="6" name="Rounded Rectangle 5"/>
+          <p:cNvPr id="7" name="Rounded Rectangle 6"/>
           <p:cNvSpPr/>
           <p:nvPr/>
         </p:nvSpPr>
@@ -4580,7 +4676,7 @@
       </p:sp>
       <p:sp>
         <p:nvSpPr>
-          <p:cNvPr id="7" name="TextBox 6"/>
+          <p:cNvPr id="8" name="TextBox 7"/>
           <p:cNvSpPr txBox="1"/>
           <p:nvPr/>
         </p:nvSpPr>
@@ -4667,7 +4763,7 @@
       </p:sp>
       <p:sp>
         <p:nvSpPr>
-          <p:cNvPr id="8" name="Rounded Rectangle 7"/>
+          <p:cNvPr id="9" name="Rounded Rectangle 8"/>
           <p:cNvSpPr/>
           <p:nvPr/>
         </p:nvSpPr>
@@ -4707,7 +4803,7 @@
       </p:sp>
       <p:sp>
         <p:nvSpPr>
-          <p:cNvPr id="9" name="TextBox 8"/>
+          <p:cNvPr id="10" name="TextBox 9"/>
           <p:cNvSpPr txBox="1"/>
           <p:nvPr/>
         </p:nvSpPr>
@@ -4870,7 +4966,7 @@
         <p:spPr>
           <a:xfrm>
             <a:off x="457200" y="182880"/>
-            <a:ext cx="11277295" cy="731520"/>
+            <a:ext cx="9144000" cy="731520"/>
           </a:xfrm>
           <a:prstGeom prst="rect">
             <a:avLst/>
@@ -4897,9 +4993,33 @@
           </a:p>
         </p:txBody>
       </p:sp>
-      <p:sp>
-        <p:nvSpPr>
-          <p:cNvPr id="4" name="Rounded Rectangle 3"/>
+      <p:pic>
+        <p:nvPicPr>
+          <p:cNvPr id="4" name="Picture 3" descr="logo.png"/>
+          <p:cNvPicPr>
+            <a:picLocks noChangeAspect="1"/>
+          </p:cNvPicPr>
+          <p:nvPr/>
+        </p:nvPicPr>
+        <p:blipFill>
+          <a:blip r:embed="rId2"/>
+          <a:stretch>
+            <a:fillRect/>
+          </a:stretch>
+        </p:blipFill>
+        <p:spPr>
+          <a:xfrm>
+            <a:off x="10972800" y="182880"/>
+            <a:ext cx="731520" cy="731520"/>
+          </a:xfrm>
+          <a:prstGeom prst="rect">
+            <a:avLst/>
+          </a:prstGeom>
+        </p:spPr>
+      </p:pic>
+      <p:sp>
+        <p:nvSpPr>
+          <p:cNvPr id="5" name="Rounded Rectangle 4"/>
           <p:cNvSpPr/>
           <p:nvPr/>
         </p:nvSpPr>
@@ -4944,7 +5064,7 @@
       </p:sp>
       <p:sp>
         <p:nvSpPr>
-          <p:cNvPr id="5" name="TextBox 4"/>
+          <p:cNvPr id="6" name="TextBox 5"/>
           <p:cNvSpPr txBox="1"/>
           <p:nvPr/>
         </p:nvSpPr>
@@ -5015,7 +5135,7 @@
       </p:sp>
       <p:sp>
         <p:nvSpPr>
-          <p:cNvPr id="6" name="Rounded Rectangle 5"/>
+          <p:cNvPr id="7" name="Rounded Rectangle 6"/>
           <p:cNvSpPr/>
           <p:nvPr/>
         </p:nvSpPr>
@@ -5060,7 +5180,7 @@
       </p:sp>
       <p:sp>
         <p:nvSpPr>
-          <p:cNvPr id="7" name="TextBox 6"/>
+          <p:cNvPr id="8" name="TextBox 7"/>
           <p:cNvSpPr txBox="1"/>
           <p:nvPr/>
         </p:nvSpPr>
@@ -5131,7 +5251,7 @@
       </p:sp>
       <p:sp>
         <p:nvSpPr>
-          <p:cNvPr id="8" name="Rounded Rectangle 7"/>
+          <p:cNvPr id="9" name="Rounded Rectangle 8"/>
           <p:cNvSpPr/>
           <p:nvPr/>
         </p:nvSpPr>
@@ -5171,7 +5291,7 @@
       </p:sp>
       <p:sp>
         <p:nvSpPr>
-          <p:cNvPr id="9" name="TextBox 8"/>
+          <p:cNvPr id="10" name="TextBox 9"/>
           <p:cNvSpPr txBox="1"/>
           <p:nvPr/>
         </p:nvSpPr>
@@ -5350,7 +5470,7 @@
         <p:spPr>
           <a:xfrm>
             <a:off x="457200" y="182880"/>
-            <a:ext cx="11277295" cy="731520"/>
+            <a:ext cx="9144000" cy="731520"/>
           </a:xfrm>
           <a:prstGeom prst="rect">
             <a:avLst/>
@@ -5372,21 +5492,45 @@
               </a:defRPr>
             </a:pPr>
             <a:r>
-              <a:t>5. Thiết Kế Cơ Sở Dữ Liệu (MySQL)</a:t>
-            </a:r>
-          </a:p>
-        </p:txBody>
-      </p:sp>
-      <p:sp>
-        <p:nvSpPr>
-          <p:cNvPr id="4" name="Rounded Rectangle 3"/>
+              <a:t>5. Thiết Kế Cơ Sở Dữ Liệu &amp; ERD</a:t>
+            </a:r>
+          </a:p>
+        </p:txBody>
+      </p:sp>
+      <p:pic>
+        <p:nvPicPr>
+          <p:cNvPr id="4" name="Picture 3" descr="logo.png"/>
+          <p:cNvPicPr>
+            <a:picLocks noChangeAspect="1"/>
+          </p:cNvPicPr>
+          <p:nvPr/>
+        </p:nvPicPr>
+        <p:blipFill>
+          <a:blip r:embed="rId2"/>
+          <a:stretch>
+            <a:fillRect/>
+          </a:stretch>
+        </p:blipFill>
+        <p:spPr>
+          <a:xfrm>
+            <a:off x="10972800" y="182880"/>
+            <a:ext cx="731520" cy="731520"/>
+          </a:xfrm>
+          <a:prstGeom prst="rect">
+            <a:avLst/>
+          </a:prstGeom>
+        </p:spPr>
+      </p:pic>
+      <p:sp>
+        <p:nvSpPr>
+          <p:cNvPr id="5" name="Rounded Rectangle 4"/>
           <p:cNvSpPr/>
           <p:nvPr/>
         </p:nvSpPr>
         <p:spPr>
           <a:xfrm>
             <a:off x="914400" y="1828800"/>
-            <a:ext cx="4754880" cy="4114800"/>
+            <a:ext cx="4389120" cy="4114800"/>
           </a:xfrm>
           <a:prstGeom prst="roundRect">
             <a:avLst/>
@@ -5424,14 +5568,14 @@
       </p:sp>
       <p:sp>
         <p:nvSpPr>
-          <p:cNvPr id="5" name="TextBox 4"/>
+          <p:cNvPr id="6" name="TextBox 5"/>
           <p:cNvSpPr txBox="1"/>
           <p:nvPr/>
         </p:nvSpPr>
         <p:spPr>
           <a:xfrm>
             <a:off x="1097280" y="2011680"/>
-            <a:ext cx="4389120" cy="3749040"/>
+            <a:ext cx="4023360" cy="3749040"/>
           </a:xfrm>
           <a:prstGeom prst="rect">
             <a:avLst/>
@@ -5488,7 +5632,7 @@
               </a:defRPr>
             </a:pPr>
             <a:r>
-              <a:t>• bai_viet, binh_luan, tuong_tac: Lưu thông tin hoạt động mạng xã hội.</a:t>
+              <a:t>• bai_viet, binh_luan: Lưu thông tin mạng xã hội.</a:t>
             </a:r>
           </a:p>
           <a:p>
@@ -5504,7 +5648,7 @@
               </a:defRPr>
             </a:pPr>
             <a:r>
-              <a:t>• dat_ve, ve_dich_vu: Quản lý thông tin đặt chỗ và trạng thái vé.</a:t>
+              <a:t>• dat_ve, ve_dich_vu: Quản lý booking vé.</a:t>
             </a:r>
           </a:p>
           <a:p>
@@ -5520,21 +5664,53 @@
               </a:defRPr>
             </a:pPr>
             <a:r>
-              <a:t>• tin_nhan, phong_chat: Quản lý thông tin nhắn tin realtime.</a:t>
-            </a:r>
-          </a:p>
-        </p:txBody>
-      </p:sp>
-      <p:sp>
-        <p:nvSpPr>
-          <p:cNvPr id="6" name="Rounded Rectangle 5"/>
+              <a:t>• tin_nhan, phong_chat: Nhắn tin realtime.</a:t>
+            </a:r>
+          </a:p>
+          <a:p>
+            <a:pPr>
+              <a:spcAft>
+                <a:spcPts val="800"/>
+              </a:spcAft>
+              <a:defRPr sz="1400">
+                <a:solidFill>
+                  <a:srgbClr val="1E293B"/>
+                </a:solidFill>
+                <a:latin typeface="Arial"/>
+              </a:defRPr>
+            </a:pPr>
+            <a:r>
+              <a:t>• Ràng buộc khóa ngoại đảm bảo tính toàn vẹn.</a:t>
+            </a:r>
+          </a:p>
+          <a:p>
+            <a:pPr>
+              <a:spcAft>
+                <a:spcPts val="800"/>
+              </a:spcAft>
+              <a:defRPr sz="1400">
+                <a:solidFill>
+                  <a:srgbClr val="1E293B"/>
+                </a:solidFill>
+                <a:latin typeface="Arial"/>
+              </a:defRPr>
+            </a:pPr>
+            <a:r>
+              <a:t>• Tối ưu hóa các truy vấn JOIN lấy dữ liệu.</a:t>
+            </a:r>
+          </a:p>
+        </p:txBody>
+      </p:sp>
+      <p:sp>
+        <p:nvSpPr>
+          <p:cNvPr id="7" name="Rounded Rectangle 6"/>
           <p:cNvSpPr/>
           <p:nvPr/>
         </p:nvSpPr>
         <p:spPr>
           <a:xfrm>
-            <a:off x="6522415" y="1828800"/>
-            <a:ext cx="4754880" cy="4114800"/>
+            <a:off x="5760720" y="1828800"/>
+            <a:ext cx="5516575" cy="4114800"/>
           </a:xfrm>
           <a:prstGeom prst="roundRect">
             <a:avLst/>
@@ -5570,109 +5746,30 @@
           </a:p>
         </p:txBody>
       </p:sp>
-      <p:sp>
-        <p:nvSpPr>
-          <p:cNvPr id="7" name="TextBox 6"/>
-          <p:cNvSpPr txBox="1"/>
+      <p:pic>
+        <p:nvPicPr>
+          <p:cNvPr id="8" name="Picture 7" descr="erd.png"/>
+          <p:cNvPicPr>
+            <a:picLocks noChangeAspect="1"/>
+          </p:cNvPicPr>
           <p:nvPr/>
-        </p:nvSpPr>
-        <p:spPr>
-          <a:xfrm>
-            <a:off x="6705295" y="2011680"/>
-            <a:ext cx="4389120" cy="3749040"/>
+        </p:nvPicPr>
+        <p:blipFill>
+          <a:blip r:embed="rId3"/>
+          <a:stretch>
+            <a:fillRect/>
+          </a:stretch>
+        </p:blipFill>
+        <p:spPr>
+          <a:xfrm>
+            <a:off x="5852160" y="1920240"/>
+            <a:ext cx="5333695" cy="3931920"/>
           </a:xfrm>
           <a:prstGeom prst="rect">
             <a:avLst/>
           </a:prstGeom>
-          <a:noFill/>
-        </p:spPr>
-        <p:txBody>
-          <a:bodyPr wrap="square">
-            <a:spAutoFit/>
-          </a:bodyPr>
-          <a:lstStyle/>
-          <a:p>
-            <a:pPr>
-              <a:spcAft>
-                <a:spcPts val="1400"/>
-              </a:spcAft>
-              <a:defRPr sz="2000" b="1">
-                <a:solidFill>
-                  <a:srgbClr val="0F172A"/>
-                </a:solidFill>
-                <a:latin typeface="Arial"/>
-              </a:defRPr>
-            </a:pPr>
-            <a:r>
-              <a:t>Đặc điểm thiết kế DB</a:t>
-            </a:r>
-          </a:p>
-          <a:p>
-            <a:pPr>
-              <a:spcAft>
-                <a:spcPts val="800"/>
-              </a:spcAft>
-              <a:defRPr sz="1400">
-                <a:solidFill>
-                  <a:srgbClr val="1E293B"/>
-                </a:solidFill>
-                <a:latin typeface="Arial"/>
-              </a:defRPr>
-            </a:pPr>
-            <a:r>
-              <a:t>• Chuẩn hóa dữ liệu để tránh dư thừa dữ liệu (Data redundancy).</a:t>
-            </a:r>
-          </a:p>
-          <a:p>
-            <a:pPr>
-              <a:spcAft>
-                <a:spcPts val="800"/>
-              </a:spcAft>
-              <a:defRPr sz="1400">
-                <a:solidFill>
-                  <a:srgbClr val="1E293B"/>
-                </a:solidFill>
-                <a:latin typeface="Arial"/>
-              </a:defRPr>
-            </a:pPr>
-            <a:r>
-              <a:t>• Sử dụng ràng buộc khóa ngoại (Foreign Keys) để đảm bảo tính toàn vẹn tham chiếu.</a:t>
-            </a:r>
-          </a:p>
-          <a:p>
-            <a:pPr>
-              <a:spcAft>
-                <a:spcPts val="800"/>
-              </a:spcAft>
-              <a:defRPr sz="1400">
-                <a:solidFill>
-                  <a:srgbClr val="1E293B"/>
-                </a:solidFill>
-                <a:latin typeface="Arial"/>
-              </a:defRPr>
-            </a:pPr>
-            <a:r>
-              <a:t>• Lưu trữ dữ liệu dạng JSON cho các thuộc tính động (ví dụ: danh sách sở thích).</a:t>
-            </a:r>
-          </a:p>
-          <a:p>
-            <a:pPr>
-              <a:spcAft>
-                <a:spcPts val="800"/>
-              </a:spcAft>
-              <a:defRPr sz="1400">
-                <a:solidFill>
-                  <a:srgbClr val="1E293B"/>
-                </a:solidFill>
-                <a:latin typeface="Arial"/>
-              </a:defRPr>
-            </a:pPr>
-            <a:r>
-              <a:t>• Tối ưu hóa các truy vấn JOIN để lấy dữ liệu bài viết kèm tương tác và thông tin người đăng.</a:t>
-            </a:r>
-          </a:p>
-        </p:txBody>
-      </p:sp>
+        </p:spPr>
+      </p:pic>
     </p:spTree>
   </p:cSld>
   <p:clrMapOvr>
@@ -5751,7 +5848,7 @@
         <p:spPr>
           <a:xfrm>
             <a:off x="457200" y="182880"/>
-            <a:ext cx="11277295" cy="731520"/>
+            <a:ext cx="9144000" cy="731520"/>
           </a:xfrm>
           <a:prstGeom prst="rect">
             <a:avLst/>
@@ -5778,9 +5875,33 @@
           </a:p>
         </p:txBody>
       </p:sp>
-      <p:sp>
-        <p:nvSpPr>
-          <p:cNvPr id="4" name="Rounded Rectangle 3"/>
+      <p:pic>
+        <p:nvPicPr>
+          <p:cNvPr id="4" name="Picture 3" descr="logo.png"/>
+          <p:cNvPicPr>
+            <a:picLocks noChangeAspect="1"/>
+          </p:cNvPicPr>
+          <p:nvPr/>
+        </p:nvPicPr>
+        <p:blipFill>
+          <a:blip r:embed="rId2"/>
+          <a:stretch>
+            <a:fillRect/>
+          </a:stretch>
+        </p:blipFill>
+        <p:spPr>
+          <a:xfrm>
+            <a:off x="10972800" y="182880"/>
+            <a:ext cx="731520" cy="731520"/>
+          </a:xfrm>
+          <a:prstGeom prst="rect">
+            <a:avLst/>
+          </a:prstGeom>
+        </p:spPr>
+      </p:pic>
+      <p:sp>
+        <p:nvSpPr>
+          <p:cNvPr id="5" name="Rounded Rectangle 4"/>
           <p:cNvSpPr/>
           <p:nvPr/>
         </p:nvSpPr>
@@ -5820,7 +5941,7 @@
       </p:sp>
       <p:sp>
         <p:nvSpPr>
-          <p:cNvPr id="5" name="TextBox 4"/>
+          <p:cNvPr id="6" name="TextBox 5"/>
           <p:cNvSpPr txBox="1"/>
           <p:nvPr/>
         </p:nvSpPr>
@@ -5907,7 +6028,7 @@
       </p:sp>
       <p:sp>
         <p:nvSpPr>
-          <p:cNvPr id="6" name="Rounded Rectangle 5"/>
+          <p:cNvPr id="7" name="Rounded Rectangle 6"/>
           <p:cNvSpPr/>
           <p:nvPr/>
         </p:nvSpPr>
@@ -5952,7 +6073,7 @@
       </p:sp>
       <p:sp>
         <p:nvSpPr>
-          <p:cNvPr id="7" name="TextBox 6"/>
+          <p:cNvPr id="8" name="TextBox 7"/>
           <p:cNvSpPr txBox="1"/>
           <p:nvPr/>
         </p:nvSpPr>
@@ -6115,7 +6236,7 @@
         <p:spPr>
           <a:xfrm>
             <a:off x="457200" y="182880"/>
-            <a:ext cx="11277295" cy="731520"/>
+            <a:ext cx="9144000" cy="731520"/>
           </a:xfrm>
           <a:prstGeom prst="rect">
             <a:avLst/>
@@ -6137,21 +6258,45 @@
               </a:defRPr>
             </a:pPr>
             <a:r>
-              <a:t>7. Demo Một Số Giao Diện Hệ Thống</a:t>
-            </a:r>
-          </a:p>
-        </p:txBody>
-      </p:sp>
-      <p:sp>
-        <p:nvSpPr>
-          <p:cNvPr id="4" name="Rounded Rectangle 3"/>
+              <a:t>7. Demo Giao Diện Thực Tế</a:t>
+            </a:r>
+          </a:p>
+        </p:txBody>
+      </p:sp>
+      <p:pic>
+        <p:nvPicPr>
+          <p:cNvPr id="4" name="Picture 3" descr="logo.png"/>
+          <p:cNvPicPr>
+            <a:picLocks noChangeAspect="1"/>
+          </p:cNvPicPr>
+          <p:nvPr/>
+        </p:nvPicPr>
+        <p:blipFill>
+          <a:blip r:embed="rId2"/>
+          <a:stretch>
+            <a:fillRect/>
+          </a:stretch>
+        </p:blipFill>
+        <p:spPr>
+          <a:xfrm>
+            <a:off x="10972800" y="182880"/>
+            <a:ext cx="731520" cy="731520"/>
+          </a:xfrm>
+          <a:prstGeom prst="rect">
+            <a:avLst/>
+          </a:prstGeom>
+        </p:spPr>
+      </p:pic>
+      <p:sp>
+        <p:nvSpPr>
+          <p:cNvPr id="5" name="Rounded Rectangle 4"/>
           <p:cNvSpPr/>
           <p:nvPr/>
         </p:nvSpPr>
         <p:spPr>
           <a:xfrm>
-            <a:off x="914400" y="1828800"/>
-            <a:ext cx="3200400" cy="4114800"/>
+            <a:off x="914400" y="1554480"/>
+            <a:ext cx="4754880" cy="4572000"/>
           </a:xfrm>
           <a:prstGeom prst="roundRect">
             <a:avLst/>
@@ -6187,16 +6332,40 @@
           </a:p>
         </p:txBody>
       </p:sp>
-      <p:sp>
-        <p:nvSpPr>
-          <p:cNvPr id="5" name="TextBox 4"/>
+      <p:pic>
+        <p:nvPicPr>
+          <p:cNvPr id="6" name="Picture 5" descr="screenshot_homepage.png"/>
+          <p:cNvPicPr>
+            <a:picLocks noChangeAspect="1"/>
+          </p:cNvPicPr>
+          <p:nvPr/>
+        </p:nvPicPr>
+        <p:blipFill>
+          <a:blip r:embed="rId3"/>
+          <a:stretch>
+            <a:fillRect/>
+          </a:stretch>
+        </p:blipFill>
+        <p:spPr>
+          <a:xfrm>
+            <a:off x="1051560" y="1691640"/>
+            <a:ext cx="4480560" cy="3017520"/>
+          </a:xfrm>
+          <a:prstGeom prst="rect">
+            <a:avLst/>
+          </a:prstGeom>
+        </p:spPr>
+      </p:pic>
+      <p:sp>
+        <p:nvSpPr>
+          <p:cNvPr id="7" name="TextBox 6"/>
           <p:cNvSpPr txBox="1"/>
           <p:nvPr/>
         </p:nvSpPr>
         <p:spPr>
           <a:xfrm>
-            <a:off x="1097280" y="2011680"/>
-            <a:ext cx="2834640" cy="3749040"/>
+            <a:off x="1051560" y="4754880"/>
+            <a:ext cx="4480560" cy="1188720"/>
           </a:xfrm>
           <a:prstGeom prst="rect">
             <a:avLst/>
@@ -6211,9 +6380,9 @@
           <a:p>
             <a:pPr>
               <a:spcAft>
-                <a:spcPts val="1400"/>
+                <a:spcPts val="400"/>
               </a:spcAft>
-              <a:defRPr sz="2000" b="1">
+              <a:defRPr sz="1600" b="1">
                 <a:solidFill>
                   <a:srgbClr val="0F172A"/>
                 </a:solidFill>
@@ -6221,182 +6390,20 @@
               </a:defRPr>
             </a:pPr>
             <a:r>
-              <a:t>Mạng Xã Hội &amp; Đặt Vé</a:t>
-            </a:r>
-          </a:p>
-          <a:p>
-            <a:pPr>
-              <a:spcAft>
-                <a:spcPts val="800"/>
-              </a:spcAft>
-              <a:defRPr sz="1400">
-                <a:solidFill>
-                  <a:srgbClr val="1E293B"/>
-                </a:solidFill>
-                <a:latin typeface="Arial"/>
-              </a:defRPr>
-            </a:pPr>
-            <a:r>
-              <a:t>• Bảng tin hiển thị bài đăng ảnh/video đẹp mắt.</a:t>
-            </a:r>
-          </a:p>
-          <a:p>
-            <a:pPr>
-              <a:spcAft>
-                <a:spcPts val="800"/>
-              </a:spcAft>
-              <a:defRPr sz="1400">
-                <a:solidFill>
-                  <a:srgbClr val="1E293B"/>
-                </a:solidFill>
-                <a:latin typeface="Arial"/>
-              </a:defRPr>
-            </a:pPr>
-            <a:r>
-              <a:t>• Trang thông tin khu du lịch với các nút Đặt vé nhanh.</a:t>
-            </a:r>
-          </a:p>
-          <a:p>
-            <a:pPr>
-              <a:spcAft>
-                <a:spcPts val="800"/>
-              </a:spcAft>
-              <a:defRPr sz="1400">
-                <a:solidFill>
-                  <a:srgbClr val="1E293B"/>
-                </a:solidFill>
-                <a:latin typeface="Arial"/>
-              </a:defRPr>
-            </a:pPr>
-            <a:r>
-              <a:t>• Biểu mẫu điền thông tin và thanh toán hóa đơn.</a:t>
-            </a:r>
-          </a:p>
-        </p:txBody>
-      </p:sp>
-      <p:sp>
-        <p:nvSpPr>
-          <p:cNvPr id="6" name="Rounded Rectangle 5"/>
-          <p:cNvSpPr/>
-          <p:nvPr/>
-        </p:nvSpPr>
-        <p:spPr>
-          <a:xfrm>
-            <a:off x="4495190" y="1828800"/>
-            <a:ext cx="3200400" cy="4114800"/>
-          </a:xfrm>
-          <a:prstGeom prst="roundRect">
-            <a:avLst/>
-          </a:prstGeom>
-          <a:solidFill>
-            <a:srgbClr val="0F172A"/>
-          </a:solidFill>
-        </p:spPr>
-        <p:style>
-          <a:lnRef idx="1">
-            <a:schemeClr val="accent1"/>
-          </a:lnRef>
-          <a:fillRef idx="3">
-            <a:schemeClr val="accent1"/>
-          </a:fillRef>
-          <a:effectRef idx="2">
-            <a:schemeClr val="accent1"/>
-          </a:effectRef>
-          <a:fontRef idx="minor">
-            <a:schemeClr val="lt1"/>
-          </a:fontRef>
-        </p:style>
-        <p:txBody>
-          <a:bodyPr rtlCol="0" anchor="ctr"/>
-          <a:lstStyle/>
-          <a:p>
-            <a:pPr algn="ctr"/>
-          </a:p>
-        </p:txBody>
-      </p:sp>
-      <p:sp>
-        <p:nvSpPr>
-          <p:cNvPr id="7" name="TextBox 6"/>
-          <p:cNvSpPr txBox="1"/>
-          <p:nvPr/>
-        </p:nvSpPr>
-        <p:spPr>
-          <a:xfrm>
-            <a:off x="4678070" y="2011680"/>
-            <a:ext cx="2834640" cy="3749040"/>
-          </a:xfrm>
-          <a:prstGeom prst="rect">
-            <a:avLst/>
-          </a:prstGeom>
-          <a:noFill/>
-        </p:spPr>
-        <p:txBody>
-          <a:bodyPr wrap="square">
-            <a:spAutoFit/>
-          </a:bodyPr>
-          <a:lstStyle/>
-          <a:p>
-            <a:pPr>
-              <a:spcAft>
-                <a:spcPts val="1400"/>
-              </a:spcAft>
-              <a:defRPr sz="2000" b="1">
-                <a:solidFill>
-                  <a:srgbClr val="0EA5E9"/>
-                </a:solidFill>
-                <a:latin typeface="Arial"/>
-              </a:defRPr>
-            </a:pPr>
-            <a:r>
-              <a:t>Nhắn Tin &amp; Gọi Video</a:t>
-            </a:r>
-          </a:p>
-          <a:p>
-            <a:pPr>
-              <a:spcAft>
-                <a:spcPts val="800"/>
-              </a:spcAft>
-              <a:defRPr sz="1400">
-                <a:solidFill>
-                  <a:srgbClr val="FFFFFF"/>
-                </a:solidFill>
-                <a:latin typeface="Arial"/>
-              </a:defRPr>
-            </a:pPr>
-            <a:r>
-              <a:t>• Khung trò chuyện thời gian thực tích hợp gửi ảnh.</a:t>
-            </a:r>
-          </a:p>
-          <a:p>
-            <a:pPr>
-              <a:spcAft>
-                <a:spcPts val="800"/>
-              </a:spcAft>
-              <a:defRPr sz="1400">
-                <a:solidFill>
-                  <a:srgbClr val="FFFFFF"/>
-                </a:solidFill>
-                <a:latin typeface="Arial"/>
-              </a:defRPr>
-            </a:pPr>
-            <a:r>
-              <a:t>• Giao diện gọi Video hiển thị trực tiếp camera local và đối phương toàn màn hình.</a:t>
-            </a:r>
-          </a:p>
-          <a:p>
-            <a:pPr>
-              <a:spcAft>
-                <a:spcPts val="800"/>
-              </a:spcAft>
-              <a:defRPr sz="1400">
-                <a:solidFill>
-                  <a:srgbClr val="FFFFFF"/>
-                </a:solidFill>
-                <a:latin typeface="Arial"/>
-              </a:defRPr>
-            </a:pPr>
-            <a:r>
-              <a:t>• Nút bật tắt mic/camera trực quan.</a:t>
+              <a:t>Trang Chủ Mạng Xã Hội &amp; Đặt Vé</a:t>
+            </a:r>
+          </a:p>
+          <a:p>
+            <a:pPr>
+              <a:defRPr sz="1200">
+                <a:solidFill>
+                  <a:srgbClr val="475569"/>
+                </a:solidFill>
+                <a:latin typeface="Arial"/>
+              </a:defRPr>
+            </a:pPr>
+            <a:r>
+              <a:t>Giao diện chính hiển thị danh sách các bài đăng review du lịch và các địa điểm nổi bật giúp người dùng dễ dàng khám phá và đặt vé trực tuyến.</a:t>
             </a:r>
           </a:p>
         </p:txBody>
@@ -6409,8 +6416,8 @@
         </p:nvSpPr>
         <p:spPr>
           <a:xfrm>
-            <a:off x="8076895" y="1828800"/>
-            <a:ext cx="3200400" cy="4114800"/>
+            <a:off x="6522415" y="1554480"/>
+            <a:ext cx="4754880" cy="4572000"/>
           </a:xfrm>
           <a:prstGeom prst="roundRect">
             <a:avLst/>
@@ -6446,16 +6453,40 @@
           </a:p>
         </p:txBody>
       </p:sp>
-      <p:sp>
-        <p:nvSpPr>
-          <p:cNvPr id="9" name="TextBox 8"/>
+      <p:pic>
+        <p:nvPicPr>
+          <p:cNvPr id="9" name="Picture 8" descr="screenshot_dashboard.png"/>
+          <p:cNvPicPr>
+            <a:picLocks noChangeAspect="1"/>
+          </p:cNvPicPr>
+          <p:nvPr/>
+        </p:nvPicPr>
+        <p:blipFill>
+          <a:blip r:embed="rId4"/>
+          <a:stretch>
+            <a:fillRect/>
+          </a:stretch>
+        </p:blipFill>
+        <p:spPr>
+          <a:xfrm>
+            <a:off x="6659575" y="1691640"/>
+            <a:ext cx="4480560" cy="3017520"/>
+          </a:xfrm>
+          <a:prstGeom prst="rect">
+            <a:avLst/>
+          </a:prstGeom>
+        </p:spPr>
+      </p:pic>
+      <p:sp>
+        <p:nvSpPr>
+          <p:cNvPr id="10" name="TextBox 9"/>
           <p:cNvSpPr txBox="1"/>
           <p:nvPr/>
         </p:nvSpPr>
         <p:spPr>
           <a:xfrm>
-            <a:off x="8259775" y="2011680"/>
-            <a:ext cx="2834640" cy="3749040"/>
+            <a:off x="6659575" y="4754880"/>
+            <a:ext cx="4480560" cy="1188720"/>
           </a:xfrm>
           <a:prstGeom prst="rect">
             <a:avLst/>
@@ -6470,9 +6501,9 @@
           <a:p>
             <a:pPr>
               <a:spcAft>
-                <a:spcPts val="1400"/>
+                <a:spcPts val="400"/>
               </a:spcAft>
-              <a:defRPr sz="2000" b="1">
+              <a:defRPr sz="1600" b="1">
                 <a:solidFill>
                   <a:srgbClr val="0F172A"/>
                 </a:solidFill>
@@ -6480,55 +6511,20 @@
               </a:defRPr>
             </a:pPr>
             <a:r>
-              <a:t>Trang Đối Tác &amp; Admin</a:t>
-            </a:r>
-          </a:p>
-          <a:p>
-            <a:pPr>
-              <a:spcAft>
-                <a:spcPts val="800"/>
-              </a:spcAft>
-              <a:defRPr sz="1400">
-                <a:solidFill>
-                  <a:srgbClr val="1E293B"/>
-                </a:solidFill>
-                <a:latin typeface="Arial"/>
-              </a:defRPr>
-            </a:pPr>
-            <a:r>
-              <a:t>• Vé QR Code gửi về cho khách hàng.</a:t>
-            </a:r>
-          </a:p>
-          <a:p>
-            <a:pPr>
-              <a:spcAft>
-                <a:spcPts val="800"/>
-              </a:spcAft>
-              <a:defRPr sz="1400">
-                <a:solidFill>
-                  <a:srgbClr val="1E293B"/>
-                </a:solidFill>
-                <a:latin typeface="Arial"/>
-              </a:defRPr>
-            </a:pPr>
-            <a:r>
-              <a:t>• Trang quản lý booking và quét mã QR check-in.</a:t>
-            </a:r>
-          </a:p>
-          <a:p>
-            <a:pPr>
-              <a:spcAft>
-                <a:spcPts val="800"/>
-              </a:spcAft>
-              <a:defRPr sz="1400">
-                <a:solidFill>
-                  <a:srgbClr val="1E293B"/>
-                </a:solidFill>
-                <a:latin typeface="Arial"/>
-              </a:defRPr>
-            </a:pPr>
-            <a:r>
-              <a:t>• Biểu đồ thống kê doanh thu theo thời gian của khu du lịch.</a:t>
+              <a:t>Trang Quản Trị Hệ Thống (Dashboard)</a:t>
+            </a:r>
+          </a:p>
+          <a:p>
+            <a:pPr>
+              <a:defRPr sz="1200">
+                <a:solidFill>
+                  <a:srgbClr val="475569"/>
+                </a:solidFill>
+                <a:latin typeface="Arial"/>
+              </a:defRPr>
+            </a:pPr>
+            <a:r>
+              <a:t>Trang thống kê số liệu tổng quan, doanh thu, quản lý booking, thông tin các khu du lịch đối tác dành cho ban quản trị và đối tác doanh nghiệp.</a:t>
             </a:r>
           </a:p>
         </p:txBody>
@@ -6611,7 +6607,7 @@
         <p:spPr>
           <a:xfrm>
             <a:off x="457200" y="182880"/>
-            <a:ext cx="11277295" cy="731520"/>
+            <a:ext cx="9144000" cy="731520"/>
           </a:xfrm>
           <a:prstGeom prst="rect">
             <a:avLst/>
@@ -6638,9 +6634,33 @@
           </a:p>
         </p:txBody>
       </p:sp>
-      <p:sp>
-        <p:nvSpPr>
-          <p:cNvPr id="4" name="Rounded Rectangle 3"/>
+      <p:pic>
+        <p:nvPicPr>
+          <p:cNvPr id="4" name="Picture 3" descr="logo.png"/>
+          <p:cNvPicPr>
+            <a:picLocks noChangeAspect="1"/>
+          </p:cNvPicPr>
+          <p:nvPr/>
+        </p:nvPicPr>
+        <p:blipFill>
+          <a:blip r:embed="rId2"/>
+          <a:stretch>
+            <a:fillRect/>
+          </a:stretch>
+        </p:blipFill>
+        <p:spPr>
+          <a:xfrm>
+            <a:off x="10972800" y="182880"/>
+            <a:ext cx="731520" cy="731520"/>
+          </a:xfrm>
+          <a:prstGeom prst="rect">
+            <a:avLst/>
+          </a:prstGeom>
+        </p:spPr>
+      </p:pic>
+      <p:sp>
+        <p:nvSpPr>
+          <p:cNvPr id="5" name="Rounded Rectangle 4"/>
           <p:cNvSpPr/>
           <p:nvPr/>
         </p:nvSpPr>
@@ -6685,7 +6705,7 @@
       </p:sp>
       <p:sp>
         <p:nvSpPr>
-          <p:cNvPr id="5" name="TextBox 4"/>
+          <p:cNvPr id="6" name="TextBox 5"/>
           <p:cNvSpPr txBox="1"/>
           <p:nvPr/>
         </p:nvSpPr>
@@ -6772,7 +6792,7 @@
       </p:sp>
       <p:sp>
         <p:nvSpPr>
-          <p:cNvPr id="6" name="Rounded Rectangle 5"/>
+          <p:cNvPr id="7" name="Rounded Rectangle 6"/>
           <p:cNvSpPr/>
           <p:nvPr/>
         </p:nvSpPr>
@@ -6812,7 +6832,7 @@
       </p:sp>
       <p:sp>
         <p:nvSpPr>
-          <p:cNvPr id="7" name="TextBox 6"/>
+          <p:cNvPr id="8" name="TextBox 7"/>
           <p:cNvSpPr txBox="1"/>
           <p:nvPr/>
         </p:nvSpPr>

</xml_diff>